<commit_message>
fix: clean website header problem statement ID to SIH25-806 and fix PowerPoint layout
</commit_message>
<xml_diff>
--- a/SIH2026_Idea_Hexagram_DelhiEV.pptx
+++ b/SIH2026_Idea_Hexagram_DelhiEV.pptx
@@ -1499,124 +1499,19 @@
           <a:p>
             <a:pPr algn="ctr" indent="0" marL="0">
               <a:buNone/>
-              <a:defRPr b="1" sz="1800">
-                <a:solidFill>
-                  <a:srgbClr val="0096FF"/>
-                </a:solidFill>
-              </a:defRPr>
-            </a:pPr>
-            <a:r>
-              <a:t>SMART INDIA HACKATHON 2025 / 2026</a:t>
+            </a:pPr>
+            <a:r>
+              <a:rPr lang="en-US" sz="2000" b="1" dirty="0">
+                <a:solidFill>
+                  <a:srgbClr val="222222"/>
+                </a:solidFill>
+                <a:latin typeface="Georgia" pitchFamily="34" charset="0"/>
+                <a:ea typeface="Georgia" pitchFamily="34" charset="-122"/>
+                <a:cs typeface="Georgia" pitchFamily="34" charset="-120"/>
+              </a:rPr>
+              <a:t>TITLE PAGE</a:t>
             </a:r>
             <a:endParaRPr lang="en-US" sz="2000" dirty="0"/>
-          </a:p>
-          <a:p>
-            <a:pPr>
-              <a:defRPr b="1" sz="1600">
-                <a:solidFill>
-                  <a:srgbClr val="0F172A"/>
-                </a:solidFill>
-              </a:defRPr>
-            </a:pPr>
-            <a:r>
-              <a:t>SIH25-806 • EV Charging Station Predictor</a:t>
-            </a:r>
-          </a:p>
-          <a:p>
-            <a:pPr>
-              <a:defRPr sz="1100">
-                <a:solidFill>
-                  <a:srgbClr val="1E293B"/>
-                </a:solidFill>
-              </a:defRPr>
-            </a:pPr>
-            <a:r>
-              <a:t>• Problem Statement Title: EV Charging Station Predictor – Optimal Site Recommendation for Delhi NCT</a:t>
-            </a:r>
-          </a:p>
-          <a:p>
-            <a:pPr>
-              <a:defRPr sz="1100">
-                <a:solidFill>
-                  <a:srgbClr val="1E293B"/>
-                </a:solidFill>
-              </a:defRPr>
-            </a:pPr>
-            <a:r>
-              <a:t>• Ministry / Agency: Ministry of Housing &amp; Urban Affairs (MoHUA)</a:t>
-            </a:r>
-          </a:p>
-          <a:p>
-            <a:pPr>
-              <a:defRPr sz="1100">
-                <a:solidFill>
-                  <a:srgbClr val="1E293B"/>
-                </a:solidFill>
-              </a:defRPr>
-            </a:pPr>
-            <a:r>
-              <a:t>• Theme &amp; Category: Smart Vehicles / Transportation &amp; Clean Tech (Software)</a:t>
-            </a:r>
-          </a:p>
-          <a:p>
-            <a:pPr>
-              <a:defRPr sz="1100">
-                <a:solidFill>
-                  <a:srgbClr val="1E293B"/>
-                </a:solidFill>
-              </a:defRPr>
-            </a:pPr>
-            <a:r>
-              <a:t>• Team Name: Hexagram</a:t>
-            </a:r>
-          </a:p>
-          <a:p>
-            <a:pPr>
-              <a:defRPr sz="1100">
-                <a:solidFill>
-                  <a:srgbClr val="1E293B"/>
-                </a:solidFill>
-              </a:defRPr>
-            </a:pPr>
-            <a:r>
-              <a:t>• Team ID: SIH2025-HEXAGRAM</a:t>
-            </a:r>
-          </a:p>
-          <a:p>
-            <a:pPr>
-              <a:defRPr sz="1100">
-                <a:solidFill>
-                  <a:srgbClr val="1E293B"/>
-                </a:solidFill>
-              </a:defRPr>
-            </a:pPr>
-            <a:r>
-              <a:t>• Team Leader: Sourav Kumar</a:t>
-            </a:r>
-          </a:p>
-          <a:p>
-            <a:pPr>
-              <a:defRPr sz="1100">
-                <a:solidFill>
-                  <a:srgbClr val="1E293B"/>
-                </a:solidFill>
-              </a:defRPr>
-            </a:pPr>
-            <a:r>
-              <a:t>• Team Members: Sumit Kumar, Rishabh Raj, Karishma Kumari Gupta, Abhas Prasad, Rishu Raj</a:t>
-            </a:r>
-          </a:p>
-          <a:p>
-            <a:pPr>
-              <a:defRPr sz="1100">
-                <a:solidFill>
-                  <a:srgbClr val="1E293B"/>
-                </a:solidFill>
-              </a:defRPr>
-            </a:pPr>
-            <a:r>
-              <a:t>• Live Prototype URL: https://souravkr114.github.io/modified-sih-project/</a:t>
-            </a:r>
           </a:p>
         </p:txBody>
       </p:sp>
@@ -1643,127 +1538,27 @@
           <a:p>
             <a:pPr indent="0" marL="0">
               <a:buNone/>
-              <a:defRPr b="1" sz="1800">
-                <a:solidFill>
-                  <a:srgbClr val="0096FF"/>
-                </a:solidFill>
-              </a:defRPr>
-            </a:pPr>
+            </a:pPr>
+            <a:r>
+              <a:rPr lang="en-US" sz="1600" b="1" dirty="0">
+                <a:solidFill>
+                  <a:srgbClr val="1B3A63"/>
+                </a:solidFill>
+              </a:rPr>
+              <a:t>• Problem Statement ID – </a:t>
+            </a:r>
             <a:pPr indent="0" marL="0">
               <a:buNone/>
             </a:pPr>
             <a:r>
-              <a:t>SMART INDIA HACKATHON 2025 / 2026</a:t>
+              <a:rPr lang="en-US" sz="1600" dirty="0">
+                <a:solidFill>
+                  <a:srgbClr val="222222"/>
+                </a:solidFill>
+              </a:rPr>
+              <a:t>SIH25-806 (as listed on portal)</a:t>
             </a:r>
             <a:endParaRPr lang="en-US" sz="1600" dirty="0"/>
-          </a:p>
-          <a:p>
-            <a:pPr>
-              <a:defRPr b="1" sz="1600">
-                <a:solidFill>
-                  <a:srgbClr val="0F172A"/>
-                </a:solidFill>
-              </a:defRPr>
-            </a:pPr>
-            <a:r>
-              <a:t>SIH25-806 • EV Charging Station Predictor</a:t>
-            </a:r>
-          </a:p>
-          <a:p>
-            <a:pPr>
-              <a:defRPr sz="1100">
-                <a:solidFill>
-                  <a:srgbClr val="1E293B"/>
-                </a:solidFill>
-              </a:defRPr>
-            </a:pPr>
-            <a:r>
-              <a:t>• Problem Statement Title: EV Charging Station Predictor – Optimal Site Recommendation for Delhi NCT</a:t>
-            </a:r>
-          </a:p>
-          <a:p>
-            <a:pPr>
-              <a:defRPr sz="1100">
-                <a:solidFill>
-                  <a:srgbClr val="1E293B"/>
-                </a:solidFill>
-              </a:defRPr>
-            </a:pPr>
-            <a:r>
-              <a:t>• Ministry / Agency: Ministry of Housing &amp; Urban Affairs (MoHUA)</a:t>
-            </a:r>
-          </a:p>
-          <a:p>
-            <a:pPr>
-              <a:defRPr sz="1100">
-                <a:solidFill>
-                  <a:srgbClr val="1E293B"/>
-                </a:solidFill>
-              </a:defRPr>
-            </a:pPr>
-            <a:r>
-              <a:t>• Theme &amp; Category: Smart Vehicles / Transportation &amp; Clean Tech (Software)</a:t>
-            </a:r>
-          </a:p>
-          <a:p>
-            <a:pPr>
-              <a:defRPr sz="1100">
-                <a:solidFill>
-                  <a:srgbClr val="1E293B"/>
-                </a:solidFill>
-              </a:defRPr>
-            </a:pPr>
-            <a:r>
-              <a:t>• Team Name: Hexagram</a:t>
-            </a:r>
-          </a:p>
-          <a:p>
-            <a:pPr>
-              <a:defRPr sz="1100">
-                <a:solidFill>
-                  <a:srgbClr val="1E293B"/>
-                </a:solidFill>
-              </a:defRPr>
-            </a:pPr>
-            <a:r>
-              <a:t>• Team ID: SIH2025-HEXAGRAM</a:t>
-            </a:r>
-          </a:p>
-          <a:p>
-            <a:pPr>
-              <a:defRPr sz="1100">
-                <a:solidFill>
-                  <a:srgbClr val="1E293B"/>
-                </a:solidFill>
-              </a:defRPr>
-            </a:pPr>
-            <a:r>
-              <a:t>• Team Leader: Sourav Kumar</a:t>
-            </a:r>
-          </a:p>
-          <a:p>
-            <a:pPr>
-              <a:defRPr sz="1100">
-                <a:solidFill>
-                  <a:srgbClr val="1E293B"/>
-                </a:solidFill>
-              </a:defRPr>
-            </a:pPr>
-            <a:r>
-              <a:t>• Team Members: Sumit Kumar, Rishabh Raj, Karishma Kumari Gupta, Abhas Prasad, Rishu Raj</a:t>
-            </a:r>
-          </a:p>
-          <a:p>
-            <a:pPr>
-              <a:defRPr sz="1100">
-                <a:solidFill>
-                  <a:srgbClr val="1E293B"/>
-                </a:solidFill>
-              </a:defRPr>
-            </a:pPr>
-            <a:r>
-              <a:t>• Live Prototype URL: https://souravkr114.github.io/modified-sih-project/</a:t>
-            </a:r>
           </a:p>
         </p:txBody>
       </p:sp>
@@ -1931,127 +1726,27 @@
           <a:p>
             <a:pPr indent="0" marL="0">
               <a:buNone/>
-              <a:defRPr b="1" sz="1800">
-                <a:solidFill>
-                  <a:srgbClr val="0096FF"/>
-                </a:solidFill>
-              </a:defRPr>
-            </a:pPr>
+            </a:pPr>
+            <a:r>
+              <a:rPr lang="en-US" sz="1600" b="1" dirty="0">
+                <a:solidFill>
+                  <a:srgbClr val="1B3A63"/>
+                </a:solidFill>
+              </a:rPr>
+              <a:t>• Team ID – </a:t>
+            </a:r>
             <a:pPr indent="0" marL="0">
               <a:buNone/>
             </a:pPr>
             <a:r>
-              <a:t>SMART INDIA HACKATHON 2025 / 2026</a:t>
+              <a:rPr lang="en-US" sz="1600" dirty="0">
+                <a:solidFill>
+                  <a:srgbClr val="222222"/>
+                </a:solidFill>
+              </a:rPr>
+              <a:t>SIH2025-HEXAGRAM</a:t>
             </a:r>
             <a:endParaRPr lang="en-US" sz="1600" dirty="0"/>
-          </a:p>
-          <a:p>
-            <a:pPr>
-              <a:defRPr b="1" sz="1600">
-                <a:solidFill>
-                  <a:srgbClr val="0F172A"/>
-                </a:solidFill>
-              </a:defRPr>
-            </a:pPr>
-            <a:r>
-              <a:t>SIH25-806 • EV Charging Station Predictor</a:t>
-            </a:r>
-          </a:p>
-          <a:p>
-            <a:pPr>
-              <a:defRPr sz="1100">
-                <a:solidFill>
-                  <a:srgbClr val="1E293B"/>
-                </a:solidFill>
-              </a:defRPr>
-            </a:pPr>
-            <a:r>
-              <a:t>• Problem Statement Title: EV Charging Station Predictor – Optimal Site Recommendation for Delhi NCT</a:t>
-            </a:r>
-          </a:p>
-          <a:p>
-            <a:pPr>
-              <a:defRPr sz="1100">
-                <a:solidFill>
-                  <a:srgbClr val="1E293B"/>
-                </a:solidFill>
-              </a:defRPr>
-            </a:pPr>
-            <a:r>
-              <a:t>• Ministry / Agency: Ministry of Housing &amp; Urban Affairs (MoHUA)</a:t>
-            </a:r>
-          </a:p>
-          <a:p>
-            <a:pPr>
-              <a:defRPr sz="1100">
-                <a:solidFill>
-                  <a:srgbClr val="1E293B"/>
-                </a:solidFill>
-              </a:defRPr>
-            </a:pPr>
-            <a:r>
-              <a:t>• Theme &amp; Category: Smart Vehicles / Transportation &amp; Clean Tech (Software)</a:t>
-            </a:r>
-          </a:p>
-          <a:p>
-            <a:pPr>
-              <a:defRPr sz="1100">
-                <a:solidFill>
-                  <a:srgbClr val="1E293B"/>
-                </a:solidFill>
-              </a:defRPr>
-            </a:pPr>
-            <a:r>
-              <a:t>• Team Name: Hexagram</a:t>
-            </a:r>
-          </a:p>
-          <a:p>
-            <a:pPr>
-              <a:defRPr sz="1100">
-                <a:solidFill>
-                  <a:srgbClr val="1E293B"/>
-                </a:solidFill>
-              </a:defRPr>
-            </a:pPr>
-            <a:r>
-              <a:t>• Team ID: SIH2025-HEXAGRAM</a:t>
-            </a:r>
-          </a:p>
-          <a:p>
-            <a:pPr>
-              <a:defRPr sz="1100">
-                <a:solidFill>
-                  <a:srgbClr val="1E293B"/>
-                </a:solidFill>
-              </a:defRPr>
-            </a:pPr>
-            <a:r>
-              <a:t>• Team Leader: Sourav Kumar</a:t>
-            </a:r>
-          </a:p>
-          <a:p>
-            <a:pPr>
-              <a:defRPr sz="1100">
-                <a:solidFill>
-                  <a:srgbClr val="1E293B"/>
-                </a:solidFill>
-              </a:defRPr>
-            </a:pPr>
-            <a:r>
-              <a:t>• Team Members: Sumit Kumar, Rishabh Raj, Karishma Kumari Gupta, Abhas Prasad, Rishu Raj</a:t>
-            </a:r>
-          </a:p>
-          <a:p>
-            <a:pPr>
-              <a:defRPr sz="1100">
-                <a:solidFill>
-                  <a:srgbClr val="1E293B"/>
-                </a:solidFill>
-              </a:defRPr>
-            </a:pPr>
-            <a:r>
-              <a:t>• Live Prototype URL: https://souravkr114.github.io/modified-sih-project/</a:t>
-            </a:r>
           </a:p>
         </p:txBody>
       </p:sp>
@@ -2096,7 +1791,7 @@
                   <a:srgbClr val="222222"/>
                 </a:solidFill>
               </a:rPr>
-              <a:t>[Your Team Name – as registered on portal]</a:t>
+              <a:t>Hexagram</a:t>
             </a:r>
             <a:endParaRPr lang="en-US" sz="1600" dirty="0"/>
           </a:p>
@@ -2195,6 +1890,65 @@
               <a:t>1</a:t>
             </a:r>
             <a:endParaRPr lang="en-US" sz="1100" dirty="0"/>
+          </a:p>
+        </p:txBody>
+      </p:sp>
+      <p:sp>
+        <p:nvSpPr>
+          <p:cNvPr id="17" name="TextBox 16"/>
+          <p:cNvSpPr txBox="1"/>
+          <p:nvPr/>
+        </p:nvSpPr>
+        <p:spPr>
+          <a:xfrm>
+            <a:off x="635000" y="4826000"/>
+            <a:ext cx="7620000" cy="1524000"/>
+          </a:xfrm>
+          <a:prstGeom prst="rect">
+            <a:avLst/>
+          </a:prstGeom>
+          <a:noFill/>
+        </p:spPr>
+        <p:txBody>
+          <a:bodyPr wrap="none">
+            <a:spAutoFit/>
+          </a:bodyPr>
+          <a:lstStyle/>
+          <a:p>
+            <a:pPr>
+              <a:defRPr sz="1200" b="1">
+                <a:solidFill>
+                  <a:srgbClr val="0F172A"/>
+                </a:solidFill>
+              </a:defRPr>
+            </a:pPr>
+            <a:r>
+              <a:t>• Team Leader: Sourav Kumar</a:t>
+            </a:r>
+          </a:p>
+          <a:p>
+            <a:pPr>
+              <a:defRPr sz="1100">
+                <a:solidFill>
+                  <a:srgbClr val="334155"/>
+                </a:solidFill>
+              </a:defRPr>
+            </a:pPr>
+            <a:r>
+              <a:t>• Members: Sumit Kumar, Rishabh Raj, Karishma Kumari Gupta, Abhas Prasad, Rishu Raj</a:t>
+            </a:r>
+          </a:p>
+          <a:p>
+            <a:pPr>
+              <a:defRPr sz="1100" b="1">
+                <a:solidFill>
+                  <a:srgbClr val="0096FF"/>
+                </a:solidFill>
+              </a:defRPr>
+            </a:pPr>
+            <a:r>
+              <a:t>• Live Prototype: https://souravkr114.github.io/modified-sih-project/</a:t>
+            </a:r>
           </a:p>
         </p:txBody>
       </p:sp>
@@ -2303,7 +2057,7 @@
                   <a:srgbClr val="6C4A9C"/>
                 </a:solidFill>
               </a:rPr>
-              <a:t>BV806</a:t>
+              <a:t>SIH25-806</a:t>
             </a:r>
             <a:endParaRPr lang="en-US" sz="950" dirty="0"/>
           </a:p>
@@ -2538,112 +2292,16 @@
           <a:p>
             <a:pPr indent="0" marL="0">
               <a:buNone/>
-              <a:defRPr b="1" sz="1300">
-                <a:solidFill>
-                  <a:srgbClr val="0284C7"/>
-                </a:solidFill>
-              </a:defRPr>
-            </a:pPr>
-            <a:r>
-              <a:t>PROPOSED SOLUTION: DELHI EV CHARGING INTELLIGENCE &amp; INVESTMENT PLATFORM</a:t>
+            </a:pPr>
+            <a:r>
+              <a:rPr lang="en-US" sz="1900" b="1" u="sng" dirty="0">
+                <a:solidFill>
+                  <a:srgbClr val="1B3A63"/>
+                </a:solidFill>
+              </a:rPr>
+              <a:t>Proposed Solution (Idea / Prototype)</a:t>
             </a:r>
             <a:endParaRPr lang="en-US" sz="1900" dirty="0"/>
-          </a:p>
-          <a:p>
-            <a:pPr>
-              <a:defRPr b="1" sz="1050">
-                <a:solidFill>
-                  <a:srgbClr val="0F172A"/>
-                </a:solidFill>
-              </a:defRPr>
-            </a:pPr>
-            <a:r>
-              <a:t>• Pillar 1: Multi-Factor Spatial GIS Scoring (S_i ∈ [0, 100]):</a:t>
-            </a:r>
-          </a:p>
-          <a:p>
-            <a:pPr>
-              <a:defRPr sz="950">
-                <a:solidFill>
-                  <a:srgbClr val="475569"/>
-                </a:solidFill>
-              </a:defRPr>
-            </a:pPr>
-            <a:r>
-              <a:t>  Fuses 6 weighted factors: EV fleet density (30%), supply gap (20%), grid substation capacity (15%), district adoption (15%), traffic corridors (10%), and POI dwell attraction (10%).</a:t>
-            </a:r>
-          </a:p>
-          <a:p>
-            <a:pPr>
-              <a:defRPr b="1" sz="1050">
-                <a:solidFill>
-                  <a:srgbClr val="0F172A"/>
-                </a:solidFill>
-              </a:defRPr>
-            </a:pPr>
-            <a:r>
-              <a:t>• Pillar 2: Explainable AI (SHAP Feature Rationale):</a:t>
-            </a:r>
-          </a:p>
-          <a:p>
-            <a:pPr>
-              <a:defRPr sz="950">
-                <a:solidFill>
-                  <a:srgbClr val="475569"/>
-                </a:solidFill>
-              </a:defRPr>
-            </a:pPr>
-            <a:r>
-              <a:t>  Replaces 'black-box ML' with game-theoretic additive feature attribution weights (φ_k) so city planners and CPOs see exactly WHY a location received Rank #1 (+24.5 traffic, +21.0 supply gap).</a:t>
-            </a:r>
-          </a:p>
-          <a:p>
-            <a:pPr>
-              <a:defRPr b="1" sz="1050">
-                <a:solidFill>
-                  <a:srgbClr val="0F172A"/>
-                </a:solidFill>
-              </a:defRPr>
-            </a:pPr>
-            <a:r>
-              <a:t>• Pillar 3: Investor Capex &amp; Financial ROI Return Simulator:</a:t>
-            </a:r>
-          </a:p>
-          <a:p>
-            <a:pPr>
-              <a:defRPr sz="950">
-                <a:solidFill>
-                  <a:srgbClr val="475569"/>
-                </a:solidFill>
-              </a:defRPr>
-            </a:pPr>
-            <a:r>
-              <a:t>  Calculates total Capex, DISCOM bulk power cost (₹6.8/kWh), annual ROI %, and payback period (months) across interactive tariff sliders (₹12–25/kWh).</a:t>
-            </a:r>
-          </a:p>
-          <a:p>
-            <a:pPr>
-              <a:defRPr b="1" sz="1050">
-                <a:solidFill>
-                  <a:srgbClr val="0F172A"/>
-                </a:solidFill>
-              </a:defRPr>
-            </a:pPr>
-            <a:r>
-              <a:t>• Dynamic Pincode &amp; POI Engine:</a:t>
-            </a:r>
-          </a:p>
-          <a:p>
-            <a:pPr>
-              <a:defRPr sz="950">
-                <a:solidFill>
-                  <a:srgbClr val="475569"/>
-                </a:solidFill>
-              </a:defRPr>
-            </a:pPr>
-            <a:r>
-              <a:t>  Enables real-time location scoring recalculation based on user Pincode, Search Radius (1–25km), and Points of Interest (Hotels, Malls, Metro Stations).</a:t>
-            </a:r>
           </a:p>
         </p:txBody>
       </p:sp>
@@ -2954,7 +2612,7 @@
                   <a:srgbClr val="6C4A9C"/>
                 </a:solidFill>
               </a:rPr>
-              <a:t>BV806</a:t>
+              <a:t>SIH25-806</a:t>
             </a:r>
             <a:endParaRPr lang="en-US" sz="950" dirty="0"/>
           </a:p>
@@ -2997,64 +2655,19 @@
           <a:p>
             <a:pPr algn="ctr" indent="0" marL="0">
               <a:buNone/>
-              <a:defRPr b="1" sz="1300">
-                <a:solidFill>
-                  <a:srgbClr val="0284C7"/>
-                </a:solidFill>
-              </a:defRPr>
-            </a:pPr>
-            <a:r>
-              <a:t>TECHNICAL APPROACH &amp; PRODUCTION ARCHITECTURE</a:t>
+            </a:pPr>
+            <a:r>
+              <a:rPr lang="en-US" sz="2800" b="1" dirty="0">
+                <a:solidFill>
+                  <a:srgbClr val="1B3A63"/>
+                </a:solidFill>
+                <a:latin typeface="Georgia" pitchFamily="34" charset="0"/>
+                <a:ea typeface="Georgia" pitchFamily="34" charset="-122"/>
+                <a:cs typeface="Georgia" pitchFamily="34" charset="-120"/>
+              </a:rPr>
+              <a:t>TECHNICAL APPROACH</a:t>
             </a:r>
             <a:endParaRPr lang="en-US" sz="2800" dirty="0"/>
-          </a:p>
-          <a:p>
-            <a:pPr>
-              <a:defRPr sz="1050">
-                <a:solidFill>
-                  <a:srgbClr val="1E293B"/>
-                </a:solidFill>
-              </a:defRPr>
-            </a:pPr>
-            <a:r>
-              <a:t>• Frontend &amp; GIS Mapping: Next.js 16 (Turbopack), React 18, TypeScript, Tailwind CSS, Leaflet.js with CartoDB Voyager Light tiles &amp; custom SVG rank markers.</a:t>
-            </a:r>
-          </a:p>
-          <a:p>
-            <a:pPr>
-              <a:defRPr sz="1050">
-                <a:solidFill>
-                  <a:srgbClr val="1E293B"/>
-                </a:solidFill>
-              </a:defRPr>
-            </a:pPr>
-            <a:r>
-              <a:t>• Dynamic Predictor Engine: Spatial Scoring Algorithm + Pincode, Radius (1–25km), and POI catchment recalculation module.</a:t>
-            </a:r>
-          </a:p>
-          <a:p>
-            <a:pPr>
-              <a:defRPr sz="1050">
-                <a:solidFill>
-                  <a:srgbClr val="1E293B"/>
-                </a:solidFill>
-              </a:defRPr>
-            </a:pPr>
-            <a:r>
-              <a:t>• Explainable AI (XAI): SHAP (SHapley Additive exPlanations) game-theoretic feature decomposition engine.</a:t>
-            </a:r>
-          </a:p>
-          <a:p>
-            <a:pPr>
-              <a:defRPr sz="1050">
-                <a:solidFill>
-                  <a:srgbClr val="1E293B"/>
-                </a:solidFill>
-              </a:defRPr>
-            </a:pPr>
-            <a:r>
-              <a:t>• Live &amp; Offline Deployment Resilience: Deployed live on GitHub Pages (souravkr114.github.io/modified-sih-project) + 100% offline single-file standalone bundle (Delhi_EV_Platform.html).</a:t>
-            </a:r>
           </a:p>
         </p:txBody>
       </p:sp>
@@ -3385,7 +2998,7 @@
                   <a:srgbClr val="6C4A9C"/>
                 </a:solidFill>
               </a:rPr>
-              <a:t>BV806</a:t>
+              <a:t>SIH25-806</a:t>
             </a:r>
             <a:endParaRPr lang="en-US" sz="950" dirty="0"/>
           </a:p>
@@ -3428,64 +3041,19 @@
           <a:p>
             <a:pPr algn="ctr" indent="0" marL="0">
               <a:buNone/>
-              <a:defRPr b="1" sz="1300">
-                <a:solidFill>
-                  <a:srgbClr val="0284C7"/>
-                </a:solidFill>
-              </a:defRPr>
-            </a:pPr>
-            <a:r>
-              <a:t>FEASIBILITY, GRID CONSTRAINTS &amp; DATA PROVENANCE</a:t>
+            </a:pPr>
+            <a:r>
+              <a:rPr lang="en-US" sz="2800" b="1" dirty="0">
+                <a:solidFill>
+                  <a:srgbClr val="1B3A63"/>
+                </a:solidFill>
+                <a:latin typeface="Georgia" pitchFamily="34" charset="0"/>
+                <a:ea typeface="Georgia" pitchFamily="34" charset="-122"/>
+                <a:cs typeface="Georgia" pitchFamily="34" charset="-120"/>
+              </a:rPr>
+              <a:t>FEASIBILITY AND VIABILITY</a:t>
             </a:r>
             <a:endParaRPr lang="en-US" sz="2800" dirty="0"/>
-          </a:p>
-          <a:p>
-            <a:pPr>
-              <a:defRPr sz="1050">
-                <a:solidFill>
-                  <a:srgbClr val="1E293B"/>
-                </a:solidFill>
-              </a:defRPr>
-            </a:pPr>
-            <a:r>
-              <a:t>• Data Provenance &amp; Quality (Rule 2 Compliance): Ground truth Delhi Govt Vahan registrations &amp; DISCOM substation capacities combined with OpenStreetMap GIS geometries and calibrated spatial proxies.</a:t>
-            </a:r>
-          </a:p>
-          <a:p>
-            <a:pPr>
-              <a:defRPr sz="1050">
-                <a:solidFill>
-                  <a:srgbClr val="1E293B"/>
-                </a:solidFill>
-              </a:defRPr>
-            </a:pPr>
-            <a:r>
-              <a:t>• Grid Substation Feasibility Index: Incorporates 11kV/33kV substation proximity, underground cable extension distance (meters), and transformer kVA readiness into location scoring.</a:t>
-            </a:r>
-          </a:p>
-          <a:p>
-            <a:pPr>
-              <a:defRPr sz="1050">
-                <a:solidFill>
-                  <a:srgbClr val="1E293B"/>
-                </a:solidFill>
-              </a:defRPr>
-            </a:pPr>
-            <a:r>
-              <a:t>• Dynamic Supply Gap Adjustment: Automatically recalculates surrounding deficit scores when new stations are commissioned to prevent market over-saturation.</a:t>
-            </a:r>
-          </a:p>
-          <a:p>
-            <a:pPr>
-              <a:defRPr sz="1050">
-                <a:solidFill>
-                  <a:srgbClr val="1E293B"/>
-                </a:solidFill>
-              </a:defRPr>
-            </a:pPr>
-            <a:r>
-              <a:t>• Proven Cost-Effective Stack: Zero server overhead using static Next.js production builds deployed to GitHub Pages.</a:t>
-            </a:r>
           </a:p>
         </p:txBody>
       </p:sp>
@@ -3775,7 +3343,7 @@
                   <a:srgbClr val="6C4A9C"/>
                 </a:solidFill>
               </a:rPr>
-              <a:t>BV806</a:t>
+              <a:t>SIH25-806</a:t>
             </a:r>
             <a:endParaRPr lang="en-US" sz="950" dirty="0"/>
           </a:p>
@@ -3818,52 +3386,19 @@
           <a:p>
             <a:pPr algn="ctr" indent="0" marL="0">
               <a:buNone/>
-              <a:defRPr b="1" sz="1300">
-                <a:solidFill>
-                  <a:srgbClr val="0284C7"/>
-                </a:solidFill>
-              </a:defRPr>
-            </a:pPr>
-            <a:r>
-              <a:t>IMPACT, BENEFITS &amp; MoHUA POLICY ALIGNMENT</a:t>
+            </a:pPr>
+            <a:r>
+              <a:rPr lang="en-US" sz="2800" b="1" dirty="0">
+                <a:solidFill>
+                  <a:srgbClr val="1B3A63"/>
+                </a:solidFill>
+                <a:latin typeface="Georgia" pitchFamily="34" charset="0"/>
+                <a:ea typeface="Georgia" pitchFamily="34" charset="-122"/>
+                <a:cs typeface="Georgia" pitchFamily="34" charset="-120"/>
+              </a:rPr>
+              <a:t>IMPACT AND BENEFITS</a:t>
             </a:r>
             <a:endParaRPr lang="en-US" sz="2800" dirty="0"/>
-          </a:p>
-          <a:p>
-            <a:pPr>
-              <a:defRPr sz="1050">
-                <a:solidFill>
-                  <a:srgbClr val="1E293B"/>
-                </a:solidFill>
-              </a:defRPr>
-            </a:pPr>
-            <a:r>
-              <a:t>• MoHUA Urban Policy Alignment: Direct tracking against official benchmark of 1 Public Charger per 25 EVs (highlighted in District Deficit Matrix).</a:t>
-            </a:r>
-          </a:p>
-          <a:p>
-            <a:pPr>
-              <a:defRPr sz="1050">
-                <a:solidFill>
-                  <a:srgbClr val="1E293B"/>
-                </a:solidFill>
-              </a:defRPr>
-            </a:pPr>
-            <a:r>
-              <a:t>• Economic Impact for Operators: De-risks private CPO capital investments by predicting payback periods (14–24 months) before building.</a:t>
-            </a:r>
-          </a:p>
-          <a:p>
-            <a:pPr>
-              <a:defRPr sz="1050">
-                <a:solidFill>
-                  <a:srgbClr val="1E293B"/>
-                </a:solidFill>
-              </a:defRPr>
-            </a:pPr>
-            <a:r>
-              <a:t>• Social &amp; Environmental Impact: Eliminates EV range anxiety, accelerates clean-air EV adoption across Delhi NCT, and prioritizes multi-modal transit hubs (ISBTs, Metro, Airport).</a:t>
-            </a:r>
           </a:p>
         </p:txBody>
       </p:sp>
@@ -4174,7 +3709,7 @@
                   <a:srgbClr val="6C4A9C"/>
                 </a:solidFill>
               </a:rPr>
-              <a:t>BV806</a:t>
+              <a:t>SIH25-806</a:t>
             </a:r>
             <a:endParaRPr lang="en-US" sz="950" dirty="0"/>
           </a:p>
@@ -4217,64 +3752,19 @@
           <a:p>
             <a:pPr algn="ctr" indent="0" marL="0">
               <a:buNone/>
-              <a:defRPr b="1" sz="1300">
-                <a:solidFill>
-                  <a:srgbClr val="0284C7"/>
-                </a:solidFill>
-              </a:defRPr>
-            </a:pPr>
-            <a:r>
-              <a:t>DEMO LINKS, CODE &amp; REFERENCES</a:t>
+            </a:pPr>
+            <a:r>
+              <a:rPr lang="en-US" sz="2800" b="1" dirty="0">
+                <a:solidFill>
+                  <a:srgbClr val="1B3A63"/>
+                </a:solidFill>
+                <a:latin typeface="Georgia" pitchFamily="34" charset="0"/>
+                <a:ea typeface="Georgia" pitchFamily="34" charset="-122"/>
+                <a:cs typeface="Georgia" pitchFamily="34" charset="-120"/>
+              </a:rPr>
+              <a:t>RESEARCH AND REFERENCES</a:t>
             </a:r>
             <a:endParaRPr lang="en-US" sz="2800" dirty="0"/>
-          </a:p>
-          <a:p>
-            <a:pPr>
-              <a:defRPr sz="1050">
-                <a:solidFill>
-                  <a:srgbClr val="1E293B"/>
-                </a:solidFill>
-              </a:defRPr>
-            </a:pPr>
-            <a:r>
-              <a:t>• Live Interactive Prototype URL: https://souravkr114.github.io/modified-sih-project/</a:t>
-            </a:r>
-          </a:p>
-          <a:p>
-            <a:pPr>
-              <a:defRPr sz="1050">
-                <a:solidFill>
-                  <a:srgbClr val="1E293B"/>
-                </a:solidFill>
-              </a:defRPr>
-            </a:pPr>
-            <a:r>
-              <a:t>• GitHub Code Repository: https://github.com/souravkr114/modified-sih-project</a:t>
-            </a:r>
-          </a:p>
-          <a:p>
-            <a:pPr>
-              <a:defRPr sz="1050">
-                <a:solidFill>
-                  <a:srgbClr val="1E293B"/>
-                </a:solidFill>
-              </a:defRPr>
-            </a:pPr>
-            <a:r>
-              <a:t>• Policy References: Delhi Electric Vehicle Policy 2026, MoHUA Urban EV Infrastructure Guidelines.</a:t>
-            </a:r>
-          </a:p>
-          <a:p>
-            <a:pPr>
-              <a:defRPr sz="1050">
-                <a:solidFill>
-                  <a:srgbClr val="1E293B"/>
-                </a:solidFill>
-              </a:defRPr>
-            </a:pPr>
-            <a:r>
-              <a:t>• Spatial Data Sources: OpenStreetMap (Roads, POIs), Delhi Metro Transit Network, DISCOM Substation Listings.</a:t>
-            </a:r>
           </a:p>
         </p:txBody>
       </p:sp>

</xml_diff>

<commit_message>
feat: add explicit overpass-api.de endpoint constant and data lineage source URL
</commit_message>
<xml_diff>
--- a/SIH2026_Idea_Hexagram_DelhiEV.pptx
+++ b/SIH2026_Idea_Hexagram_DelhiEV.pptx
@@ -4,6 +4,9 @@
   <p:sldMasterIdLst>
     <p:sldMasterId id="2147483648" r:id="rId1"/>
   </p:sldMasterIdLst>
+  <p:notesMasterIdLst>
+    <p:notesMasterId r:id="rId8"/>
+  </p:notesMasterIdLst>
   <p:sldIdLst>
     <p:sldId id="256" r:id="rId2"/>
     <p:sldId id="257" r:id="rId3"/>
@@ -12,9 +15,6 @@
     <p:sldId id="260" r:id="rId6"/>
     <p:sldId id="261" r:id="rId7"/>
   </p:sldIdLst>
-  <p:notesMasterIdLst>
-    <p:notesMasterId r:id="rId8"/>
-  </p:notesMasterIdLst>
   <p:sldSz cx="12192000" cy="6858000"/>
   <p:notesSz cx="6858000" cy="12192000"/>
   <p:defaultTextStyle>
@@ -109,7 +109,57 @@
       </a:defRPr>
     </a:lvl9pPr>
   </p:defaultTextStyle>
+  <p:extLst>
+    <p:ext uri="{EFAFB233-063F-42B5-8137-9DF3F51BA10A}">
+      <p15:sldGuideLst xmlns:p15="http://schemas.microsoft.com/office/powerpoint/2012/main"/>
+    </p:ext>
+  </p:extLst>
 </p:presentation>
+</file>
+
+<file path=ppt/changesInfos/changesInfo1.xml><?xml version="1.0" encoding="utf-8"?>
+<pc:chgInfo xmlns:a="http://schemas.openxmlformats.org/drawingml/2006/main" xmlns:r="http://schemas.openxmlformats.org/officeDocument/2006/relationships" xmlns:ac="http://schemas.microsoft.com/office/drawing/2013/main/command" xmlns:pc="http://schemas.microsoft.com/office/powerpoint/2013/main/command">
+  <pc:docChgLst>
+    <pc:chgData name="SOURAV KUMAR" userId="ec32c5db61774507" providerId="LiveId" clId="{D8F440F8-315E-484A-9BAF-95ED1AADD39D}"/>
+    <pc:docChg chg="modSld">
+      <pc:chgData name="SOURAV KUMAR" userId="ec32c5db61774507" providerId="LiveId" clId="{D8F440F8-315E-484A-9BAF-95ED1AADD39D}" dt="2026-08-25T12:42:17.509" v="28" actId="1076"/>
+      <pc:docMkLst>
+        <pc:docMk/>
+      </pc:docMkLst>
+      <pc:sldChg chg="modSp mod">
+        <pc:chgData name="SOURAV KUMAR" userId="ec32c5db61774507" providerId="LiveId" clId="{D8F440F8-315E-484A-9BAF-95ED1AADD39D}" dt="2026-08-25T12:42:17.509" v="28" actId="1076"/>
+        <pc:sldMkLst>
+          <pc:docMk/>
+          <pc:sldMk cId="0" sldId="256"/>
+        </pc:sldMkLst>
+        <pc:spChg chg="mod">
+          <ac:chgData name="SOURAV KUMAR" userId="ec32c5db61774507" providerId="LiveId" clId="{D8F440F8-315E-484A-9BAF-95ED1AADD39D}" dt="2026-08-25T12:40:45.446" v="26" actId="20577"/>
+          <ac:spMkLst>
+            <pc:docMk/>
+            <pc:sldMk cId="0" sldId="256"/>
+            <ac:spMk id="8" creationId="{00000000-0000-0000-0000-000000000000}"/>
+          </ac:spMkLst>
+        </pc:spChg>
+        <pc:spChg chg="mod">
+          <ac:chgData name="SOURAV KUMAR" userId="ec32c5db61774507" providerId="LiveId" clId="{D8F440F8-315E-484A-9BAF-95ED1AADD39D}" dt="2026-08-25T12:42:08.688" v="27" actId="1076"/>
+          <ac:spMkLst>
+            <pc:docMk/>
+            <pc:sldMk cId="0" sldId="256"/>
+            <ac:spMk id="13" creationId="{00000000-0000-0000-0000-000000000000}"/>
+          </ac:spMkLst>
+        </pc:spChg>
+        <pc:spChg chg="mod">
+          <ac:chgData name="SOURAV KUMAR" userId="ec32c5db61774507" providerId="LiveId" clId="{D8F440F8-315E-484A-9BAF-95ED1AADD39D}" dt="2026-08-25T12:42:17.509" v="28" actId="1076"/>
+          <ac:spMkLst>
+            <pc:docMk/>
+            <pc:sldMk cId="0" sldId="256"/>
+            <ac:spMk id="17" creationId="{00000000-0000-0000-0000-000000000000}"/>
+          </ac:spMkLst>
+        </pc:spChg>
+      </pc:sldChg>
+    </pc:docChg>
+  </pc:docChgLst>
+</pc:chgInfo>
 </file>
 
 <file path=ppt/notesMasters/notesMaster1.xml><?xml version="1.0" encoding="utf-8"?>
@@ -134,234 +184,10 @@
           <a:chExt cx="0" cy="0"/>
         </a:xfrm>
       </p:grpSpPr>
-      <p:sp>
-        <p:nvSpPr>
-          <p:cNvPr id="2" name="Header Placeholder 1"/>
-          <p:cNvSpPr>
-            <a:spLocks noGrp="1"/>
-          </p:cNvSpPr>
-          <p:nvPr>
-            <p:ph type="hdr" sz="quarter"/>
-          </p:nvPr>
-        </p:nvSpPr>
-        <p:spPr>
-          <a:xfrm>
-            <a:off x="0" y="0"/>
-            <a:ext cx="2971800" cy="458788"/>
-          </a:xfrm>
-          <a:prstGeom prst="rect">
-            <a:avLst/>
-          </a:prstGeom>
-        </p:spPr>
-        <p:txBody>
-          <a:bodyPr vert="horz" lIns="91440" tIns="45720" rIns="91440" bIns="45720" rtlCol="0"/>
-          <a:lstStyle>
-            <a:lvl1pPr algn="l">
-              <a:defRPr sz="1200"/>
-            </a:lvl1pPr>
-          </a:lstStyle>
-          <a:p>
-            <a:endParaRPr lang="en-US"/>
-          </a:p>
-        </p:txBody>
-      </p:sp>
-      <p:sp>
-        <p:nvSpPr>
-          <p:cNvPr id="3" name="Date Placeholder 2"/>
-          <p:cNvSpPr>
-            <a:spLocks noGrp="1"/>
-          </p:cNvSpPr>
-          <p:nvPr>
-            <p:ph type="dt" idx="1"/>
-          </p:nvPr>
-        </p:nvSpPr>
-        <p:spPr>
-          <a:xfrm>
-            <a:off x="3884613" y="0"/>
-            <a:ext cx="2971800" cy="458788"/>
-          </a:xfrm>
-          <a:prstGeom prst="rect">
-            <a:avLst/>
-          </a:prstGeom>
-        </p:spPr>
-        <p:txBody>
-          <a:bodyPr vert="horz" lIns="91440" tIns="45720" rIns="91440" bIns="45720" rtlCol="0"/>
-          <a:lstStyle>
-            <a:lvl1pPr algn="r">
-              <a:defRPr sz="1200"/>
-            </a:lvl1pPr>
-          </a:lstStyle>
-          <a:p>
-            <a:fld id="{5282F153-3F37-0F45-9E97-73ACFA13230C}" type="datetimeFigureOut">
-              <a:rPr lang="en-US"/>
-              <a:t>7/23/19</a:t>
-            </a:fld>
-            <a:endParaRPr lang="en-US"/>
-          </a:p>
-        </p:txBody>
-      </p:sp>
-      <p:sp>
-        <p:nvSpPr>
-          <p:cNvPr id="4" name="Slide Image Placeholder 3"/>
-          <p:cNvSpPr>
-            <a:spLocks noGrp="1" noRot="1" noChangeAspect="1"/>
-          </p:cNvSpPr>
-          <p:nvPr>
-            <p:ph type="sldImg" idx="2"/>
-          </p:nvPr>
-        </p:nvSpPr>
-        <p:spPr>
-          <a:xfrm>
-            <a:off x="685800" y="1143000"/>
-            <a:ext cx="5486400" cy="3086100"/>
-          </a:xfrm>
-          <a:prstGeom prst="rect">
-            <a:avLst/>
-          </a:prstGeom>
-          <a:noFill/>
-          <a:ln w="12700">
-            <a:solidFill>
-              <a:prstClr val="black"/>
-            </a:solidFill>
-          </a:ln>
-        </p:spPr>
-        <p:txBody>
-          <a:bodyPr vert="horz" lIns="91440" tIns="45720" rIns="91440" bIns="45720" rtlCol="0" anchor="ctr"/>
-          <a:lstStyle/>
-          <a:p>
-            <a:endParaRPr lang="en-US"/>
-          </a:p>
-        </p:txBody>
-      </p:sp>
-      <p:sp>
-        <p:nvSpPr>
-          <p:cNvPr id="5" name="Notes Placeholder 4"/>
-          <p:cNvSpPr>
-            <a:spLocks noGrp="1"/>
-          </p:cNvSpPr>
-          <p:nvPr>
-            <p:ph type="body" sz="quarter" idx="3"/>
-          </p:nvPr>
-        </p:nvSpPr>
-        <p:spPr>
-          <a:xfrm>
-            <a:off x="685800" y="4400550"/>
-            <a:ext cx="5486400" cy="3600450"/>
-          </a:xfrm>
-          <a:prstGeom prst="rect">
-            <a:avLst/>
-          </a:prstGeom>
-        </p:spPr>
-        <p:txBody>
-          <a:bodyPr vert="horz" lIns="91440" tIns="45720" rIns="91440" bIns="45720" rtlCol="0"/>
-          <a:lstStyle/>
-          <a:p>
-            <a:pPr lvl="0"/>
-            <a:r>
-              <a:rPr lang="en-US"/>
-              <a:t>Click to edit Master text styles</a:t>
-            </a:r>
-          </a:p>
-          <a:p>
-            <a:pPr lvl="1"/>
-            <a:r>
-              <a:rPr lang="en-US"/>
-              <a:t>Second level</a:t>
-            </a:r>
-          </a:p>
-          <a:p>
-            <a:pPr lvl="2"/>
-            <a:r>
-              <a:rPr lang="en-US"/>
-              <a:t>Third level</a:t>
-            </a:r>
-          </a:p>
-          <a:p>
-            <a:pPr lvl="3"/>
-            <a:r>
-              <a:rPr lang="en-US"/>
-              <a:t>Fourth level</a:t>
-            </a:r>
-          </a:p>
-          <a:p>
-            <a:pPr lvl="4"/>
-            <a:r>
-              <a:rPr lang="en-US"/>
-              <a:t>Fifth level</a:t>
-            </a:r>
-          </a:p>
-        </p:txBody>
-      </p:sp>
-      <p:sp>
-        <p:nvSpPr>
-          <p:cNvPr id="6" name="Footer Placeholder 5"/>
-          <p:cNvSpPr>
-            <a:spLocks noGrp="1"/>
-          </p:cNvSpPr>
-          <p:nvPr>
-            <p:ph type="ftr" sz="quarter" idx="4"/>
-          </p:nvPr>
-        </p:nvSpPr>
-        <p:spPr>
-          <a:xfrm>
-            <a:off x="0" y="8685213"/>
-            <a:ext cx="2971800" cy="458787"/>
-          </a:xfrm>
-          <a:prstGeom prst="rect">
-            <a:avLst/>
-          </a:prstGeom>
-        </p:spPr>
-        <p:txBody>
-          <a:bodyPr vert="horz" lIns="91440" tIns="45720" rIns="91440" bIns="45720" rtlCol="0" anchor="b"/>
-          <a:lstStyle>
-            <a:lvl1pPr algn="l">
-              <a:defRPr sz="1200"/>
-            </a:lvl1pPr>
-          </a:lstStyle>
-          <a:p>
-            <a:endParaRPr lang="en-US"/>
-          </a:p>
-        </p:txBody>
-      </p:sp>
-      <p:sp>
-        <p:nvSpPr>
-          <p:cNvPr id="7" name="Slide Number Placeholder 6"/>
-          <p:cNvSpPr>
-            <a:spLocks noGrp="1"/>
-          </p:cNvSpPr>
-          <p:nvPr>
-            <p:ph type="sldNum" sz="quarter" idx="5"/>
-          </p:nvPr>
-        </p:nvSpPr>
-        <p:spPr>
-          <a:xfrm>
-            <a:off x="3884613" y="8685213"/>
-            <a:ext cx="2971800" cy="458787"/>
-          </a:xfrm>
-          <a:prstGeom prst="rect">
-            <a:avLst/>
-          </a:prstGeom>
-        </p:spPr>
-        <p:txBody>
-          <a:bodyPr vert="horz" lIns="91440" tIns="45720" rIns="91440" bIns="45720" rtlCol="0" anchor="b"/>
-          <a:lstStyle>
-            <a:lvl1pPr algn="r">
-              <a:defRPr sz="1200"/>
-            </a:lvl1pPr>
-          </a:lstStyle>
-          <a:p>
-            <a:fld id="{CE5E9CC1-C706-0F49-92D6-E571CC5EEA8F}" type="slidenum">
-              <a:rPr lang="en-US"/>
-              <a:t>‹#›</a:t>
-            </a:fld>
-            <a:endParaRPr lang="en-US"/>
-          </a:p>
-        </p:txBody>
-      </p:sp>
     </p:spTree>
     <p:extLst>
       <p:ext uri="{BB962C8B-B14F-4D97-AF65-F5344CB8AC3E}">
-        <p14:creationId xmlns:p14="http://schemas.microsoft.com/office/powerpoint/2010/main" val="1024086991"/>
+        <p14:creationId xmlns:p14="http://schemas.microsoft.com/office/powerpoint/2010/main" val="1375221324"/>
       </p:ext>
     </p:extLst>
   </p:cSld>
@@ -505,10 +331,6 @@
           <a:bodyPr/>
           <a:lstStyle/>
           <a:p>
-            <a:r>
-              <a:rPr lang="en-US" dirty="0"/>
-              <a:t/>
-            </a:r>
             <a:endParaRPr lang="en-US" dirty="0"/>
           </a:p>
         </p:txBody>
@@ -593,10 +415,6 @@
           <a:bodyPr/>
           <a:lstStyle/>
           <a:p>
-            <a:r>
-              <a:rPr lang="en-US" dirty="0"/>
-              <a:t/>
-            </a:r>
             <a:endParaRPr lang="en-US" dirty="0"/>
           </a:p>
         </p:txBody>
@@ -681,10 +499,6 @@
           <a:bodyPr/>
           <a:lstStyle/>
           <a:p>
-            <a:r>
-              <a:rPr lang="en-US" dirty="0"/>
-              <a:t/>
-            </a:r>
             <a:endParaRPr lang="en-US" dirty="0"/>
           </a:p>
         </p:txBody>
@@ -769,10 +583,6 @@
           <a:bodyPr/>
           <a:lstStyle/>
           <a:p>
-            <a:r>
-              <a:rPr lang="en-US" dirty="0"/>
-              <a:t/>
-            </a:r>
             <a:endParaRPr lang="en-US" dirty="0"/>
           </a:p>
         </p:txBody>
@@ -857,10 +667,6 @@
           <a:bodyPr/>
           <a:lstStyle/>
           <a:p>
-            <a:r>
-              <a:rPr lang="en-US" dirty="0"/>
-              <a:t/>
-            </a:r>
             <a:endParaRPr lang="en-US" dirty="0"/>
           </a:p>
         </p:txBody>
@@ -945,10 +751,6 @@
           <a:bodyPr/>
           <a:lstStyle/>
           <a:p>
-            <a:r>
-              <a:rPr lang="en-US" dirty="0"/>
-              <a:t/>
-            </a:r>
             <a:endParaRPr lang="en-US" dirty="0"/>
           </a:p>
         </p:txBody>
@@ -1022,6 +824,11 @@
 <file path=ppt/slideMasters/slideMaster1.xml><?xml version="1.0" encoding="utf-8"?>
 <p:sldMaster xmlns:a="http://schemas.openxmlformats.org/drawingml/2006/main" xmlns:r="http://schemas.openxmlformats.org/officeDocument/2006/relationships" xmlns:p="http://schemas.openxmlformats.org/presentationml/2006/main">
   <p:cSld>
+    <p:bg>
+      <p:bgRef idx="1001">
+        <a:schemeClr val="bg1"/>
+      </p:bgRef>
+    </p:bg>
     <p:spTree>
       <p:nvGrpSpPr>
         <p:cNvPr id="1" name=""/>
@@ -1304,6 +1111,7 @@
         <a:solidFill>
           <a:srgbClr val="FFFFFF"/>
         </a:solidFill>
+        <a:effectLst/>
       </p:bgPr>
     </p:bg>
     <p:spTree>
@@ -1341,7 +1149,7 @@
           <a:bodyPr wrap="square" rtlCol="0" anchor="ctr"/>
           <a:lstStyle/>
           <a:p>
-            <a:pPr algn="ctr" indent="0" marL="0">
+            <a:pPr marL="0" indent="0" algn="ctr">
               <a:buNone/>
             </a:pPr>
             <a:r>
@@ -1385,7 +1193,10 @@
         </p:spPr>
         <p:txBody>
           <a:bodyPr/>
-          <a:p/>
+          <a:lstStyle/>
+          <a:p>
+            <a:endParaRPr/>
+          </a:p>
         </p:txBody>
       </p:sp>
       <p:sp>
@@ -1411,7 +1222,10 @@
         </p:spPr>
         <p:txBody>
           <a:bodyPr/>
-          <a:p/>
+          <a:lstStyle/>
+          <a:p>
+            <a:endParaRPr/>
+          </a:p>
         </p:txBody>
       </p:sp>
       <p:sp>
@@ -1437,7 +1251,10 @@
         </p:spPr>
         <p:txBody>
           <a:bodyPr/>
-          <a:p/>
+          <a:lstStyle/>
+          <a:p>
+            <a:endParaRPr/>
+          </a:p>
         </p:txBody>
       </p:sp>
       <p:sp>
@@ -1461,7 +1278,7 @@
           <a:bodyPr wrap="square" rtlCol="0" anchor="ctr"/>
           <a:lstStyle/>
           <a:p>
-            <a:pPr algn="ctr" indent="0" marL="0">
+            <a:pPr marL="0" indent="0" algn="ctr">
               <a:buNone/>
             </a:pPr>
             <a:r>
@@ -1497,7 +1314,7 @@
           <a:bodyPr wrap="square" rtlCol="0" anchor="ctr"/>
           <a:lstStyle/>
           <a:p>
-            <a:pPr algn="ctr" indent="0" marL="0">
+            <a:pPr marL="0" indent="0" algn="ctr">
               <a:buNone/>
             </a:pPr>
             <a:r>
@@ -1536,7 +1353,7 @@
           <a:bodyPr wrap="square" rtlCol="0" anchor="ctr"/>
           <a:lstStyle/>
           <a:p>
-            <a:pPr indent="0" marL="0">
+            <a:pPr marL="0" indent="0">
               <a:buNone/>
             </a:pPr>
             <a:r>
@@ -1545,18 +1362,23 @@
                   <a:srgbClr val="1B3A63"/>
                 </a:solidFill>
               </a:rPr>
-              <a:t>• Problem Statement ID – </a:t>
-            </a:r>
-            <a:pPr indent="0" marL="0">
-              <a:buNone/>
-            </a:pPr>
-            <a:r>
-              <a:rPr lang="en-US" sz="1600" dirty="0">
+              <a:t>• Problem Statement ID </a:t>
+            </a:r>
+            <a:r>
+              <a:rPr lang="en-US" sz="1600" b="1">
+                <a:solidFill>
+                  <a:srgbClr val="1B3A63"/>
+                </a:solidFill>
+              </a:rPr>
+              <a:t>– </a:t>
+            </a:r>
+            <a:r>
+              <a:rPr lang="en-US" sz="1600">
                 <a:solidFill>
                   <a:srgbClr val="222222"/>
                 </a:solidFill>
               </a:rPr>
-              <a:t>SIH25-806 (as listed on portal)</a:t>
+              <a:t>SIH25-806</a:t>
             </a:r>
             <a:endParaRPr lang="en-US" sz="1600" dirty="0"/>
           </a:p>
@@ -1583,7 +1405,7 @@
           <a:bodyPr wrap="square" rtlCol="0" anchor="ctr"/>
           <a:lstStyle/>
           <a:p>
-            <a:pPr indent="0" marL="0">
+            <a:pPr marL="0" indent="0">
               <a:buNone/>
             </a:pPr>
             <a:r>
@@ -1594,9 +1416,6 @@
               </a:rPr>
               <a:t>• Problem Statement Title – </a:t>
             </a:r>
-            <a:pPr indent="0" marL="0">
-              <a:buNone/>
-            </a:pPr>
             <a:r>
               <a:rPr lang="en-US" sz="1600" dirty="0">
                 <a:solidFill>
@@ -1630,7 +1449,7 @@
           <a:bodyPr wrap="square" rtlCol="0" anchor="ctr"/>
           <a:lstStyle/>
           <a:p>
-            <a:pPr indent="0" marL="0">
+            <a:pPr marL="0" indent="0">
               <a:buNone/>
             </a:pPr>
             <a:r>
@@ -1641,9 +1460,6 @@
               </a:rPr>
               <a:t>• Theme – </a:t>
             </a:r>
-            <a:pPr indent="0" marL="0">
-              <a:buNone/>
-            </a:pPr>
             <a:r>
               <a:rPr lang="en-US" sz="1600" dirty="0">
                 <a:solidFill>
@@ -1677,7 +1493,7 @@
           <a:bodyPr wrap="square" rtlCol="0" anchor="ctr"/>
           <a:lstStyle/>
           <a:p>
-            <a:pPr indent="0" marL="0">
+            <a:pPr marL="0" indent="0">
               <a:buNone/>
             </a:pPr>
             <a:r>
@@ -1688,9 +1504,6 @@
               </a:rPr>
               <a:t>• PS Category – </a:t>
             </a:r>
-            <a:pPr indent="0" marL="0">
-              <a:buNone/>
-            </a:pPr>
             <a:r>
               <a:rPr lang="en-US" sz="1600" dirty="0">
                 <a:solidFill>
@@ -1724,7 +1537,7 @@
           <a:bodyPr wrap="square" rtlCol="0" anchor="ctr"/>
           <a:lstStyle/>
           <a:p>
-            <a:pPr indent="0" marL="0">
+            <a:pPr marL="0" indent="0">
               <a:buNone/>
             </a:pPr>
             <a:r>
@@ -1735,46 +1548,43 @@
               </a:rPr>
               <a:t>• Team ID – </a:t>
             </a:r>
-            <a:pPr indent="0" marL="0">
+            <a:r>
+              <a:rPr lang="en-US" sz="1600" dirty="0">
+                <a:solidFill>
+                  <a:srgbClr val="222222"/>
+                </a:solidFill>
+              </a:rPr>
+              <a:t>SIH2025-HEXAGRAM</a:t>
+            </a:r>
+            <a:endParaRPr lang="en-US" sz="1600" dirty="0"/>
+          </a:p>
+        </p:txBody>
+      </p:sp>
+      <p:sp>
+        <p:nvSpPr>
+          <p:cNvPr id="13" name="Text 11"/>
+          <p:cNvSpPr/>
+          <p:nvPr/>
+        </p:nvSpPr>
+        <p:spPr>
+          <a:xfrm>
+            <a:off x="731520" y="5523730"/>
+            <a:ext cx="10725912" cy="502920"/>
+          </a:xfrm>
+          <a:prstGeom prst="rect">
+            <a:avLst/>
+          </a:prstGeom>
+          <a:noFill/>
+          <a:ln/>
+        </p:spPr>
+        <p:txBody>
+          <a:bodyPr wrap="square" rtlCol="0" anchor="ctr"/>
+          <a:lstStyle/>
+          <a:p>
+            <a:pPr marL="0" indent="0">
               <a:buNone/>
             </a:pPr>
             <a:r>
-              <a:rPr lang="en-US" sz="1600" dirty="0">
-                <a:solidFill>
-                  <a:srgbClr val="222222"/>
-                </a:solidFill>
-              </a:rPr>
-              <a:t>SIH2025-HEXAGRAM</a:t>
-            </a:r>
-            <a:endParaRPr lang="en-US" sz="1600" dirty="0"/>
-          </a:p>
-        </p:txBody>
-      </p:sp>
-      <p:sp>
-        <p:nvSpPr>
-          <p:cNvPr id="13" name="Text 11"/>
-          <p:cNvSpPr/>
-          <p:nvPr/>
-        </p:nvSpPr>
-        <p:spPr>
-          <a:xfrm>
-            <a:off x="731520" y="5303520"/>
-            <a:ext cx="10725912" cy="502920"/>
-          </a:xfrm>
-          <a:prstGeom prst="rect">
-            <a:avLst/>
-          </a:prstGeom>
-          <a:noFill/>
-          <a:ln/>
-        </p:spPr>
-        <p:txBody>
-          <a:bodyPr wrap="square" rtlCol="0" anchor="ctr"/>
-          <a:lstStyle/>
-          <a:p>
-            <a:pPr indent="0" marL="0">
-              <a:buNone/>
-            </a:pPr>
-            <a:r>
               <a:rPr lang="en-US" sz="1600" b="1" dirty="0">
                 <a:solidFill>
                   <a:srgbClr val="1B3A63"/>
@@ -1782,9 +1592,6 @@
               </a:rPr>
               <a:t>• Team Name – </a:t>
             </a:r>
-            <a:pPr indent="0" marL="0">
-              <a:buNone/>
-            </a:pPr>
             <a:r>
               <a:rPr lang="en-US" sz="1600" dirty="0">
                 <a:solidFill>
@@ -1818,7 +1625,10 @@
         </p:spPr>
         <p:txBody>
           <a:bodyPr/>
-          <a:p/>
+          <a:lstStyle/>
+          <a:p>
+            <a:endParaRPr/>
+          </a:p>
         </p:txBody>
       </p:sp>
       <p:sp>
@@ -1842,7 +1652,7 @@
           <a:bodyPr wrap="square" rtlCol="0" anchor="ctr"/>
           <a:lstStyle/>
           <a:p>
-            <a:pPr indent="0" marL="0">
+            <a:pPr marL="0" indent="0">
               <a:buNone/>
             </a:pPr>
             <a:r>
@@ -1878,7 +1688,7 @@
           <a:bodyPr wrap="square" rtlCol="0" anchor="ctr"/>
           <a:lstStyle/>
           <a:p>
-            <a:pPr algn="ctr" indent="0" marL="0">
+            <a:pPr marL="0" indent="0" algn="ctr">
               <a:buNone/>
             </a:pPr>
             <a:r>
@@ -1901,8 +1711,8 @@
         </p:nvSpPr>
         <p:spPr>
           <a:xfrm>
-            <a:off x="635000" y="4826000"/>
-            <a:ext cx="7620000" cy="1524000"/>
+            <a:off x="933291" y="4992303"/>
+            <a:ext cx="5266542" cy="615553"/>
           </a:xfrm>
           <a:prstGeom prst="rect">
             <a:avLst/>
@@ -1910,7 +1720,7 @@
           <a:noFill/>
         </p:spPr>
         <p:txBody>
-          <a:bodyPr wrap="none">
+          <a:bodyPr wrap="square">
             <a:spAutoFit/>
           </a:bodyPr>
           <a:lstStyle/>
@@ -1923,6 +1733,7 @@
               </a:defRPr>
             </a:pPr>
             <a:r>
+              <a:rPr dirty="0"/>
               <a:t>• Team Leader: Sourav Kumar</a:t>
             </a:r>
           </a:p>
@@ -1935,6 +1746,7 @@
               </a:defRPr>
             </a:pPr>
             <a:r>
+              <a:rPr dirty="0"/>
               <a:t>• Members: Sumit Kumar, Rishabh Raj, Karishma Kumari Gupta, Abhas Prasad, Rishu Raj</a:t>
             </a:r>
           </a:p>
@@ -1947,6 +1759,7 @@
               </a:defRPr>
             </a:pPr>
             <a:r>
+              <a:rPr dirty="0"/>
               <a:t>• Live Prototype: https://souravkr114.github.io/modified-sih-project/</a:t>
             </a:r>
           </a:p>
@@ -1968,6 +1781,7 @@
         <a:solidFill>
           <a:srgbClr val="FFFFFF"/>
         </a:solidFill>
+        <a:effectLst/>
       </p:bgPr>
     </p:bg>
     <p:spTree>
@@ -2010,7 +1824,10 @@
         </p:spPr>
         <p:txBody>
           <a:bodyPr/>
-          <a:p/>
+          <a:lstStyle/>
+          <a:p>
+            <a:endParaRPr/>
+          </a:p>
         </p:txBody>
       </p:sp>
       <p:sp>
@@ -2034,7 +1851,7 @@
           <a:bodyPr wrap="square" rtlCol="0" anchor="ctr"/>
           <a:lstStyle/>
           <a:p>
-            <a:pPr algn="ctr" indent="0" marL="0">
+            <a:pPr marL="0" indent="0" algn="ctr">
               <a:buNone/>
             </a:pPr>
             <a:r>
@@ -2048,7 +1865,7 @@
             <a:endParaRPr lang="en-US" sz="950" dirty="0"/>
           </a:p>
           <a:p>
-            <a:pPr algn="ctr" indent="0" marL="0">
+            <a:pPr marL="0" indent="0" algn="ctr">
               <a:buNone/>
             </a:pPr>
             <a:r>
@@ -2062,7 +1879,7 @@
             <a:endParaRPr lang="en-US" sz="950" dirty="0"/>
           </a:p>
           <a:p>
-            <a:pPr algn="ctr" indent="0" marL="0">
+            <a:pPr marL="0" indent="0" algn="ctr">
               <a:buNone/>
             </a:pPr>
             <a:r>
@@ -2103,7 +1920,10 @@
         </p:spPr>
         <p:txBody>
           <a:bodyPr/>
-          <a:p/>
+          <a:lstStyle/>
+          <a:p>
+            <a:endParaRPr/>
+          </a:p>
         </p:txBody>
       </p:sp>
       <p:sp>
@@ -2129,7 +1949,10 @@
         </p:spPr>
         <p:txBody>
           <a:bodyPr/>
-          <a:p/>
+          <a:lstStyle/>
+          <a:p>
+            <a:endParaRPr/>
+          </a:p>
         </p:txBody>
       </p:sp>
       <p:sp>
@@ -2155,7 +1978,10 @@
         </p:spPr>
         <p:txBody>
           <a:bodyPr/>
-          <a:p/>
+          <a:lstStyle/>
+          <a:p>
+            <a:endParaRPr/>
+          </a:p>
         </p:txBody>
       </p:sp>
       <p:sp>
@@ -2179,7 +2005,7 @@
           <a:bodyPr wrap="square" rtlCol="0" anchor="ctr"/>
           <a:lstStyle/>
           <a:p>
-            <a:pPr algn="ctr" indent="0" marL="0">
+            <a:pPr marL="0" indent="0" algn="ctr">
               <a:buNone/>
             </a:pPr>
             <a:r>
@@ -2215,7 +2041,7 @@
           <a:bodyPr wrap="square" rtlCol="0" anchor="ctr"/>
           <a:lstStyle/>
           <a:p>
-            <a:pPr algn="ctr" indent="0" marL="0">
+            <a:pPr marL="0" indent="0" algn="ctr">
               <a:buNone/>
             </a:pPr>
             <a:r>
@@ -2254,7 +2080,7 @@
           <a:bodyPr wrap="square" rtlCol="0" anchor="ctr"/>
           <a:lstStyle/>
           <a:p>
-            <a:pPr algn="ctr" indent="0" marL="0">
+            <a:pPr marL="0" indent="0" algn="ctr">
               <a:buNone/>
             </a:pPr>
             <a:r>
@@ -2290,7 +2116,7 @@
           <a:bodyPr wrap="square" rtlCol="0" anchor="ctr"/>
           <a:lstStyle/>
           <a:p>
-            <a:pPr indent="0" marL="0">
+            <a:pPr marL="0" indent="0">
               <a:buNone/>
             </a:pPr>
             <a:r>
@@ -2432,7 +2258,10 @@
         </p:spPr>
         <p:txBody>
           <a:bodyPr/>
-          <a:p/>
+          <a:lstStyle/>
+          <a:p>
+            <a:endParaRPr/>
+          </a:p>
         </p:txBody>
       </p:sp>
       <p:sp>
@@ -2456,7 +2285,7 @@
           <a:bodyPr wrap="square" rtlCol="0" anchor="ctr"/>
           <a:lstStyle/>
           <a:p>
-            <a:pPr indent="0" marL="0">
+            <a:pPr marL="0" indent="0">
               <a:buNone/>
             </a:pPr>
             <a:r>
@@ -2492,7 +2321,7 @@
           <a:bodyPr wrap="square" rtlCol="0" anchor="ctr"/>
           <a:lstStyle/>
           <a:p>
-            <a:pPr algn="ctr" indent="0" marL="0">
+            <a:pPr marL="0" indent="0" algn="ctr">
               <a:buNone/>
             </a:pPr>
             <a:r>
@@ -2523,6 +2352,7 @@
         <a:solidFill>
           <a:srgbClr val="FFFFFF"/>
         </a:solidFill>
+        <a:effectLst/>
       </p:bgPr>
     </p:bg>
     <p:spTree>
@@ -2565,7 +2395,10 @@
         </p:spPr>
         <p:txBody>
           <a:bodyPr/>
-          <a:p/>
+          <a:lstStyle/>
+          <a:p>
+            <a:endParaRPr/>
+          </a:p>
         </p:txBody>
       </p:sp>
       <p:sp>
@@ -2589,7 +2422,7 @@
           <a:bodyPr wrap="square" rtlCol="0" anchor="ctr"/>
           <a:lstStyle/>
           <a:p>
-            <a:pPr algn="ctr" indent="0" marL="0">
+            <a:pPr marL="0" indent="0" algn="ctr">
               <a:buNone/>
             </a:pPr>
             <a:r>
@@ -2603,7 +2436,7 @@
             <a:endParaRPr lang="en-US" sz="950" dirty="0"/>
           </a:p>
           <a:p>
-            <a:pPr algn="ctr" indent="0" marL="0">
+            <a:pPr marL="0" indent="0" algn="ctr">
               <a:buNone/>
             </a:pPr>
             <a:r>
@@ -2617,7 +2450,7 @@
             <a:endParaRPr lang="en-US" sz="950" dirty="0"/>
           </a:p>
           <a:p>
-            <a:pPr algn="ctr" indent="0" marL="0">
+            <a:pPr marL="0" indent="0" algn="ctr">
               <a:buNone/>
             </a:pPr>
             <a:r>
@@ -2653,7 +2486,7 @@
           <a:bodyPr wrap="square" rtlCol="0" anchor="ctr"/>
           <a:lstStyle/>
           <a:p>
-            <a:pPr algn="ctr" indent="0" marL="0">
+            <a:pPr marL="0" indent="0" algn="ctr">
               <a:buNone/>
             </a:pPr>
             <a:r>
@@ -2776,7 +2609,7 @@
             <a:endParaRPr lang="en-US" sz="1600" dirty="0"/>
           </a:p>
           <a:p>
-            <a:pPr indent="0" marL="0">
+            <a:pPr marL="0" indent="0">
               <a:lnSpc>
                 <a:spcPct val="115000"/>
               </a:lnSpc>
@@ -2818,7 +2651,10 @@
         </p:spPr>
         <p:txBody>
           <a:bodyPr/>
-          <a:p/>
+          <a:lstStyle/>
+          <a:p>
+            <a:endParaRPr/>
+          </a:p>
         </p:txBody>
       </p:sp>
       <p:sp>
@@ -2842,7 +2678,7 @@
           <a:bodyPr wrap="square" rtlCol="0" anchor="ctr"/>
           <a:lstStyle/>
           <a:p>
-            <a:pPr indent="0" marL="0">
+            <a:pPr marL="0" indent="0">
               <a:buNone/>
             </a:pPr>
             <a:r>
@@ -2878,7 +2714,7 @@
           <a:bodyPr wrap="square" rtlCol="0" anchor="ctr"/>
           <a:lstStyle/>
           <a:p>
-            <a:pPr algn="ctr" indent="0" marL="0">
+            <a:pPr marL="0" indent="0" algn="ctr">
               <a:buNone/>
             </a:pPr>
             <a:r>
@@ -2909,6 +2745,7 @@
         <a:solidFill>
           <a:srgbClr val="FFFFFF"/>
         </a:solidFill>
+        <a:effectLst/>
       </p:bgPr>
     </p:bg>
     <p:spTree>
@@ -2951,7 +2788,10 @@
         </p:spPr>
         <p:txBody>
           <a:bodyPr/>
-          <a:p/>
+          <a:lstStyle/>
+          <a:p>
+            <a:endParaRPr/>
+          </a:p>
         </p:txBody>
       </p:sp>
       <p:sp>
@@ -2975,7 +2815,7 @@
           <a:bodyPr wrap="square" rtlCol="0" anchor="ctr"/>
           <a:lstStyle/>
           <a:p>
-            <a:pPr algn="ctr" indent="0" marL="0">
+            <a:pPr marL="0" indent="0" algn="ctr">
               <a:buNone/>
             </a:pPr>
             <a:r>
@@ -2989,7 +2829,7 @@
             <a:endParaRPr lang="en-US" sz="950" dirty="0"/>
           </a:p>
           <a:p>
-            <a:pPr algn="ctr" indent="0" marL="0">
+            <a:pPr marL="0" indent="0" algn="ctr">
               <a:buNone/>
             </a:pPr>
             <a:r>
@@ -3003,7 +2843,7 @@
             <a:endParaRPr lang="en-US" sz="950" dirty="0"/>
           </a:p>
           <a:p>
-            <a:pPr algn="ctr" indent="0" marL="0">
+            <a:pPr marL="0" indent="0" algn="ctr">
               <a:buNone/>
             </a:pPr>
             <a:r>
@@ -3039,7 +2879,7 @@
           <a:bodyPr wrap="square" rtlCol="0" anchor="ctr"/>
           <a:lstStyle/>
           <a:p>
-            <a:pPr algn="ctr" indent="0" marL="0">
+            <a:pPr marL="0" indent="0" algn="ctr">
               <a:buNone/>
             </a:pPr>
             <a:r>
@@ -3163,7 +3003,10 @@
         </p:spPr>
         <p:txBody>
           <a:bodyPr/>
-          <a:p/>
+          <a:lstStyle/>
+          <a:p>
+            <a:endParaRPr/>
+          </a:p>
         </p:txBody>
       </p:sp>
       <p:sp>
@@ -3187,7 +3030,7 @@
           <a:bodyPr wrap="square" rtlCol="0" anchor="ctr"/>
           <a:lstStyle/>
           <a:p>
-            <a:pPr indent="0" marL="0">
+            <a:pPr marL="0" indent="0">
               <a:buNone/>
             </a:pPr>
             <a:r>
@@ -3223,7 +3066,7 @@
           <a:bodyPr wrap="square" rtlCol="0" anchor="ctr"/>
           <a:lstStyle/>
           <a:p>
-            <a:pPr algn="ctr" indent="0" marL="0">
+            <a:pPr marL="0" indent="0" algn="ctr">
               <a:buNone/>
             </a:pPr>
             <a:r>
@@ -3254,6 +3097,7 @@
         <a:solidFill>
           <a:srgbClr val="FFFFFF"/>
         </a:solidFill>
+        <a:effectLst/>
       </p:bgPr>
     </p:bg>
     <p:spTree>
@@ -3296,7 +3140,10 @@
         </p:spPr>
         <p:txBody>
           <a:bodyPr/>
-          <a:p/>
+          <a:lstStyle/>
+          <a:p>
+            <a:endParaRPr/>
+          </a:p>
         </p:txBody>
       </p:sp>
       <p:sp>
@@ -3320,7 +3167,7 @@
           <a:bodyPr wrap="square" rtlCol="0" anchor="ctr"/>
           <a:lstStyle/>
           <a:p>
-            <a:pPr algn="ctr" indent="0" marL="0">
+            <a:pPr marL="0" indent="0" algn="ctr">
               <a:buNone/>
             </a:pPr>
             <a:r>
@@ -3334,7 +3181,7 @@
             <a:endParaRPr lang="en-US" sz="950" dirty="0"/>
           </a:p>
           <a:p>
-            <a:pPr algn="ctr" indent="0" marL="0">
+            <a:pPr marL="0" indent="0" algn="ctr">
               <a:buNone/>
             </a:pPr>
             <a:r>
@@ -3348,7 +3195,7 @@
             <a:endParaRPr lang="en-US" sz="950" dirty="0"/>
           </a:p>
           <a:p>
-            <a:pPr algn="ctr" indent="0" marL="0">
+            <a:pPr marL="0" indent="0" algn="ctr">
               <a:buNone/>
             </a:pPr>
             <a:r>
@@ -3384,7 +3231,7 @@
           <a:bodyPr wrap="square" rtlCol="0" anchor="ctr"/>
           <a:lstStyle/>
           <a:p>
-            <a:pPr algn="ctr" indent="0" marL="0">
+            <a:pPr marL="0" indent="0" algn="ctr">
               <a:buNone/>
             </a:pPr>
             <a:r>
@@ -3529,7 +3376,10 @@
         </p:spPr>
         <p:txBody>
           <a:bodyPr/>
-          <a:p/>
+          <a:lstStyle/>
+          <a:p>
+            <a:endParaRPr/>
+          </a:p>
         </p:txBody>
       </p:sp>
       <p:sp>
@@ -3553,7 +3403,7 @@
           <a:bodyPr wrap="square" rtlCol="0" anchor="ctr"/>
           <a:lstStyle/>
           <a:p>
-            <a:pPr indent="0" marL="0">
+            <a:pPr marL="0" indent="0">
               <a:buNone/>
             </a:pPr>
             <a:r>
@@ -3589,7 +3439,7 @@
           <a:bodyPr wrap="square" rtlCol="0" anchor="ctr"/>
           <a:lstStyle/>
           <a:p>
-            <a:pPr algn="ctr" indent="0" marL="0">
+            <a:pPr marL="0" indent="0" algn="ctr">
               <a:buNone/>
             </a:pPr>
             <a:r>
@@ -3620,6 +3470,7 @@
         <a:solidFill>
           <a:srgbClr val="FFFFFF"/>
         </a:solidFill>
+        <a:effectLst/>
       </p:bgPr>
     </p:bg>
     <p:spTree>
@@ -3662,7 +3513,10 @@
         </p:spPr>
         <p:txBody>
           <a:bodyPr/>
-          <a:p/>
+          <a:lstStyle/>
+          <a:p>
+            <a:endParaRPr/>
+          </a:p>
         </p:txBody>
       </p:sp>
       <p:sp>
@@ -3686,7 +3540,7 @@
           <a:bodyPr wrap="square" rtlCol="0" anchor="ctr"/>
           <a:lstStyle/>
           <a:p>
-            <a:pPr algn="ctr" indent="0" marL="0">
+            <a:pPr marL="0" indent="0" algn="ctr">
               <a:buNone/>
             </a:pPr>
             <a:r>
@@ -3700,7 +3554,7 @@
             <a:endParaRPr lang="en-US" sz="950" dirty="0"/>
           </a:p>
           <a:p>
-            <a:pPr algn="ctr" indent="0" marL="0">
+            <a:pPr marL="0" indent="0" algn="ctr">
               <a:buNone/>
             </a:pPr>
             <a:r>
@@ -3714,7 +3568,7 @@
             <a:endParaRPr lang="en-US" sz="950" dirty="0"/>
           </a:p>
           <a:p>
-            <a:pPr algn="ctr" indent="0" marL="0">
+            <a:pPr marL="0" indent="0" algn="ctr">
               <a:buNone/>
             </a:pPr>
             <a:r>
@@ -3750,7 +3604,7 @@
           <a:bodyPr wrap="square" rtlCol="0" anchor="ctr"/>
           <a:lstStyle/>
           <a:p>
-            <a:pPr algn="ctr" indent="0" marL="0">
+            <a:pPr marL="0" indent="0" algn="ctr">
               <a:buNone/>
             </a:pPr>
             <a:r>
@@ -3895,7 +3749,10 @@
         </p:spPr>
         <p:txBody>
           <a:bodyPr/>
-          <a:p/>
+          <a:lstStyle/>
+          <a:p>
+            <a:endParaRPr/>
+          </a:p>
         </p:txBody>
       </p:sp>
       <p:sp>
@@ -3919,7 +3776,7 @@
           <a:bodyPr wrap="square" rtlCol="0" anchor="ctr"/>
           <a:lstStyle/>
           <a:p>
-            <a:pPr indent="0" marL="0">
+            <a:pPr marL="0" indent="0">
               <a:buNone/>
             </a:pPr>
             <a:r>
@@ -3955,7 +3812,7 @@
           <a:bodyPr wrap="square" rtlCol="0" anchor="ctr"/>
           <a:lstStyle/>
           <a:p>
-            <a:pPr algn="ctr" indent="0" marL="0">
+            <a:pPr marL="0" indent="0" algn="ctr">
               <a:buNone/>
             </a:pPr>
             <a:r>
@@ -4271,4 +4128,319 @@
     </a:ext>
   </a:extLst>
 </a:theme>
+</file>
+
+<file path=ppt/theme/theme2.xml><?xml version="1.0" encoding="utf-8"?>
+<a:theme xmlns:a="http://schemas.openxmlformats.org/drawingml/2006/main" name="Office Theme">
+  <a:themeElements>
+    <a:clrScheme name="Office">
+      <a:dk1>
+        <a:sysClr val="windowText" lastClr="000000"/>
+      </a:dk1>
+      <a:lt1>
+        <a:sysClr val="window" lastClr="FFFFFF"/>
+      </a:lt1>
+      <a:dk2>
+        <a:srgbClr val="0E2841"/>
+      </a:dk2>
+      <a:lt2>
+        <a:srgbClr val="E8E8E8"/>
+      </a:lt2>
+      <a:accent1>
+        <a:srgbClr val="156082"/>
+      </a:accent1>
+      <a:accent2>
+        <a:srgbClr val="E97132"/>
+      </a:accent2>
+      <a:accent3>
+        <a:srgbClr val="196B24"/>
+      </a:accent3>
+      <a:accent4>
+        <a:srgbClr val="0F9ED5"/>
+      </a:accent4>
+      <a:accent5>
+        <a:srgbClr val="A02B93"/>
+      </a:accent5>
+      <a:accent6>
+        <a:srgbClr val="4EA72E"/>
+      </a:accent6>
+      <a:hlink>
+        <a:srgbClr val="467886"/>
+      </a:hlink>
+      <a:folHlink>
+        <a:srgbClr val="96607D"/>
+      </a:folHlink>
+    </a:clrScheme>
+    <a:fontScheme name="Office">
+      <a:majorFont>
+        <a:latin typeface="Aptos Display" panose="02110004020202020204"/>
+        <a:ea typeface=""/>
+        <a:cs typeface=""/>
+        <a:font script="Jpan" typeface="游ゴシック Light"/>
+        <a:font script="Hang" typeface="맑은 고딕"/>
+        <a:font script="Hans" typeface="等线 Light"/>
+        <a:font script="Hant" typeface="新細明體"/>
+        <a:font script="Arab" typeface="Times New Roman"/>
+        <a:font script="Hebr" typeface="Times New Roman"/>
+        <a:font script="Thai" typeface="Angsana New"/>
+        <a:font script="Ethi" typeface="Nyala"/>
+        <a:font script="Beng" typeface="Vrinda"/>
+        <a:font script="Gujr" typeface="Shruti"/>
+        <a:font script="Khmr" typeface="MoolBoran"/>
+        <a:font script="Knda" typeface="Tunga"/>
+        <a:font script="Guru" typeface="Raavi"/>
+        <a:font script="Cans" typeface="Euphemia"/>
+        <a:font script="Cher" typeface="Plantagenet Cherokee"/>
+        <a:font script="Yiii" typeface="Microsoft Yi Baiti"/>
+        <a:font script="Tibt" typeface="Microsoft Himalaya"/>
+        <a:font script="Thaa" typeface="MV Boli"/>
+        <a:font script="Deva" typeface="Mangal"/>
+        <a:font script="Telu" typeface="Gautami"/>
+        <a:font script="Taml" typeface="Latha"/>
+        <a:font script="Syrc" typeface="Estrangelo Edessa"/>
+        <a:font script="Orya" typeface="Kalinga"/>
+        <a:font script="Mlym" typeface="Kartika"/>
+        <a:font script="Laoo" typeface="DokChampa"/>
+        <a:font script="Sinh" typeface="Iskoola Pota"/>
+        <a:font script="Mong" typeface="Mongolian Baiti"/>
+        <a:font script="Viet" typeface="Times New Roman"/>
+        <a:font script="Uigh" typeface="Microsoft Uighur"/>
+        <a:font script="Geor" typeface="Sylfaen"/>
+        <a:font script="Armn" typeface="Arial"/>
+        <a:font script="Bugi" typeface="Leelawadee UI"/>
+        <a:font script="Bopo" typeface="Microsoft JhengHei"/>
+        <a:font script="Java" typeface="Javanese Text"/>
+        <a:font script="Lisu" typeface="Segoe UI"/>
+        <a:font script="Mymr" typeface="Myanmar Text"/>
+        <a:font script="Nkoo" typeface="Ebrima"/>
+        <a:font script="Olck" typeface="Nirmala UI"/>
+        <a:font script="Osma" typeface="Ebrima"/>
+        <a:font script="Phag" typeface="Phagspa"/>
+        <a:font script="Syrn" typeface="Estrangelo Edessa"/>
+        <a:font script="Syrj" typeface="Estrangelo Edessa"/>
+        <a:font script="Syre" typeface="Estrangelo Edessa"/>
+        <a:font script="Sora" typeface="Nirmala UI"/>
+        <a:font script="Tale" typeface="Microsoft Tai Le"/>
+        <a:font script="Talu" typeface="Microsoft New Tai Lue"/>
+        <a:font script="Tfng" typeface="Ebrima"/>
+      </a:majorFont>
+      <a:minorFont>
+        <a:latin typeface="Aptos" panose="02110004020202020204"/>
+        <a:ea typeface=""/>
+        <a:cs typeface=""/>
+        <a:font script="Jpan" typeface="游ゴシック"/>
+        <a:font script="Hang" typeface="맑은 고딕"/>
+        <a:font script="Hans" typeface="等线"/>
+        <a:font script="Hant" typeface="新細明體"/>
+        <a:font script="Arab" typeface="Arial"/>
+        <a:font script="Hebr" typeface="Arial"/>
+        <a:font script="Thai" typeface="Cordia New"/>
+        <a:font script="Ethi" typeface="Nyala"/>
+        <a:font script="Beng" typeface="Vrinda"/>
+        <a:font script="Gujr" typeface="Shruti"/>
+        <a:font script="Khmr" typeface="DaunPenh"/>
+        <a:font script="Knda" typeface="Tunga"/>
+        <a:font script="Guru" typeface="Raavi"/>
+        <a:font script="Cans" typeface="Euphemia"/>
+        <a:font script="Cher" typeface="Plantagenet Cherokee"/>
+        <a:font script="Yiii" typeface="Microsoft Yi Baiti"/>
+        <a:font script="Tibt" typeface="Microsoft Himalaya"/>
+        <a:font script="Thaa" typeface="MV Boli"/>
+        <a:font script="Deva" typeface="Mangal"/>
+        <a:font script="Telu" typeface="Gautami"/>
+        <a:font script="Taml" typeface="Latha"/>
+        <a:font script="Syrc" typeface="Estrangelo Edessa"/>
+        <a:font script="Orya" typeface="Kalinga"/>
+        <a:font script="Mlym" typeface="Kartika"/>
+        <a:font script="Laoo" typeface="DokChampa"/>
+        <a:font script="Sinh" typeface="Iskoola Pota"/>
+        <a:font script="Mong" typeface="Mongolian Baiti"/>
+        <a:font script="Viet" typeface="Arial"/>
+        <a:font script="Uigh" typeface="Microsoft Uighur"/>
+        <a:font script="Geor" typeface="Sylfaen"/>
+        <a:font script="Armn" typeface="Arial"/>
+        <a:font script="Bugi" typeface="Leelawadee UI"/>
+        <a:font script="Bopo" typeface="Microsoft JhengHei"/>
+        <a:font script="Java" typeface="Javanese Text"/>
+        <a:font script="Lisu" typeface="Segoe UI"/>
+        <a:font script="Mymr" typeface="Myanmar Text"/>
+        <a:font script="Nkoo" typeface="Ebrima"/>
+        <a:font script="Olck" typeface="Nirmala UI"/>
+        <a:font script="Osma" typeface="Ebrima"/>
+        <a:font script="Phag" typeface="Phagspa"/>
+        <a:font script="Syrn" typeface="Estrangelo Edessa"/>
+        <a:font script="Syrj" typeface="Estrangelo Edessa"/>
+        <a:font script="Syre" typeface="Estrangelo Edessa"/>
+        <a:font script="Sora" typeface="Nirmala UI"/>
+        <a:font script="Tale" typeface="Microsoft Tai Le"/>
+        <a:font script="Talu" typeface="Microsoft New Tai Lue"/>
+        <a:font script="Tfng" typeface="Ebrima"/>
+      </a:minorFont>
+    </a:fontScheme>
+    <a:fmtScheme name="Office">
+      <a:fillStyleLst>
+        <a:solidFill>
+          <a:schemeClr val="phClr"/>
+        </a:solidFill>
+        <a:gradFill rotWithShape="1">
+          <a:gsLst>
+            <a:gs pos="0">
+              <a:schemeClr val="phClr">
+                <a:lumMod val="110000"/>
+                <a:satMod val="105000"/>
+                <a:tint val="67000"/>
+              </a:schemeClr>
+            </a:gs>
+            <a:gs pos="50000">
+              <a:schemeClr val="phClr">
+                <a:lumMod val="105000"/>
+                <a:satMod val="103000"/>
+                <a:tint val="73000"/>
+              </a:schemeClr>
+            </a:gs>
+            <a:gs pos="100000">
+              <a:schemeClr val="phClr">
+                <a:lumMod val="105000"/>
+                <a:satMod val="109000"/>
+                <a:tint val="81000"/>
+              </a:schemeClr>
+            </a:gs>
+          </a:gsLst>
+          <a:lin ang="5400000" scaled="0"/>
+        </a:gradFill>
+        <a:gradFill rotWithShape="1">
+          <a:gsLst>
+            <a:gs pos="0">
+              <a:schemeClr val="phClr">
+                <a:satMod val="103000"/>
+                <a:lumMod val="102000"/>
+                <a:tint val="94000"/>
+              </a:schemeClr>
+            </a:gs>
+            <a:gs pos="50000">
+              <a:schemeClr val="phClr">
+                <a:satMod val="110000"/>
+                <a:lumMod val="100000"/>
+                <a:shade val="100000"/>
+              </a:schemeClr>
+            </a:gs>
+            <a:gs pos="100000">
+              <a:schemeClr val="phClr">
+                <a:lumMod val="99000"/>
+                <a:satMod val="120000"/>
+                <a:shade val="78000"/>
+              </a:schemeClr>
+            </a:gs>
+          </a:gsLst>
+          <a:lin ang="5400000" scaled="0"/>
+        </a:gradFill>
+      </a:fillStyleLst>
+      <a:lnStyleLst>
+        <a:ln w="12700" cap="flat" cmpd="sng" algn="ctr">
+          <a:solidFill>
+            <a:schemeClr val="phClr"/>
+          </a:solidFill>
+          <a:prstDash val="solid"/>
+          <a:miter lim="800000"/>
+        </a:ln>
+        <a:ln w="19050" cap="flat" cmpd="sng" algn="ctr">
+          <a:solidFill>
+            <a:schemeClr val="phClr"/>
+          </a:solidFill>
+          <a:prstDash val="solid"/>
+          <a:miter lim="800000"/>
+        </a:ln>
+        <a:ln w="25400" cap="flat" cmpd="sng" algn="ctr">
+          <a:solidFill>
+            <a:schemeClr val="phClr"/>
+          </a:solidFill>
+          <a:prstDash val="solid"/>
+          <a:miter lim="800000"/>
+        </a:ln>
+      </a:lnStyleLst>
+      <a:effectStyleLst>
+        <a:effectStyle>
+          <a:effectLst/>
+        </a:effectStyle>
+        <a:effectStyle>
+          <a:effectLst/>
+        </a:effectStyle>
+        <a:effectStyle>
+          <a:effectLst>
+            <a:outerShdw blurRad="57150" dist="19050" dir="5400000" algn="ctr" rotWithShape="0">
+              <a:srgbClr val="000000">
+                <a:alpha val="63000"/>
+              </a:srgbClr>
+            </a:outerShdw>
+          </a:effectLst>
+        </a:effectStyle>
+      </a:effectStyleLst>
+      <a:bgFillStyleLst>
+        <a:solidFill>
+          <a:schemeClr val="phClr"/>
+        </a:solidFill>
+        <a:solidFill>
+          <a:schemeClr val="phClr">
+            <a:tint val="95000"/>
+            <a:satMod val="170000"/>
+          </a:schemeClr>
+        </a:solidFill>
+        <a:gradFill rotWithShape="1">
+          <a:gsLst>
+            <a:gs pos="0">
+              <a:schemeClr val="phClr">
+                <a:tint val="93000"/>
+                <a:satMod val="150000"/>
+                <a:shade val="98000"/>
+                <a:lumMod val="102000"/>
+              </a:schemeClr>
+            </a:gs>
+            <a:gs pos="50000">
+              <a:schemeClr val="phClr">
+                <a:tint val="98000"/>
+                <a:satMod val="130000"/>
+                <a:shade val="90000"/>
+                <a:lumMod val="103000"/>
+              </a:schemeClr>
+            </a:gs>
+            <a:gs pos="100000">
+              <a:schemeClr val="phClr">
+                <a:shade val="63000"/>
+                <a:satMod val="120000"/>
+              </a:schemeClr>
+            </a:gs>
+          </a:gsLst>
+          <a:lin ang="5400000" scaled="0"/>
+        </a:gradFill>
+      </a:bgFillStyleLst>
+    </a:fmtScheme>
+  </a:themeElements>
+  <a:objectDefaults>
+    <a:lnDef>
+      <a:spPr/>
+      <a:bodyPr/>
+      <a:lstStyle/>
+      <a:style>
+        <a:lnRef idx="2">
+          <a:schemeClr val="accent1"/>
+        </a:lnRef>
+        <a:fillRef idx="0">
+          <a:schemeClr val="accent1"/>
+        </a:fillRef>
+        <a:effectRef idx="1">
+          <a:schemeClr val="accent1"/>
+        </a:effectRef>
+        <a:fontRef idx="minor">
+          <a:schemeClr val="tx1"/>
+        </a:fontRef>
+      </a:style>
+    </a:lnDef>
+  </a:objectDefaults>
+  <a:extraClrSchemeLst/>
+  <a:extLst>
+    <a:ext uri="{05A4C25C-085E-4340-85A3-A5531E510DB2}">
+      <thm15:themeFamily xmlns:thm15="http://schemas.microsoft.com/office/thememl/2012/main" name="Office Theme" id="{2E142A2C-CD16-42D6-873A-C26D2A0506FA}" vid="{1BDDFF52-6CD6-40A5-AB3C-68EB2F1E4D0A}"/>
+    </a:ext>
+  </a:extLst>
+</a:theme>
 </file>
</xml_diff>